<commit_message>
Remove final presentation slide as requested
</commit_message>
<xml_diff>
--- a/presentation/customer-intelligence-system-guide.pptx
+++ b/presentation/customer-intelligence-system-guide.pptx
@@ -1,45 +1,44 @@
 
 <file path=ppt/presentation.xml><?xml version="1.0" encoding="utf-8"?>
-<p:presentation xmlns:p="http://schemas.openxmlformats.org/presentationml/2006/main">
+<p:presentation xmlns:p="http://schemas.openxmlformats.org/presentationml/2006/main" xmlns:r="http://schemas.openxmlformats.org/officeDocument/2006/relationships">
   <p:sldMasterIdLst>
-    <p:sldMasterId xmlns:r="http://schemas.openxmlformats.org/officeDocument/2006/relationships" id="2147483648" r:id="Rb8d19e8fb6154e84"/>
+    <p:sldMasterId id="2147483648" r:id="Rb8d19e8fb6154e84"/>
   </p:sldMasterIdLst>
   <p:notesMasterIdLst>
-    <p:notesMasterId xmlns:r="http://schemas.openxmlformats.org/officeDocument/2006/relationships" r:id="R374357e111b44370"/>
+    <p:notesMasterId r:id="R374357e111b44370"/>
   </p:notesMasterIdLst>
   <p:sldIdLst>
-    <p:sldId xmlns:r="http://schemas.openxmlformats.org/officeDocument/2006/relationships" id="256" r:id="Rf26c61c082b34e56"/>
-    <p:sldId xmlns:r="http://schemas.openxmlformats.org/officeDocument/2006/relationships" id="257" r:id="R306f1c47cb6343fb"/>
-    <p:sldId xmlns:r="http://schemas.openxmlformats.org/officeDocument/2006/relationships" id="258" r:id="R904562a8597f4bb7"/>
-    <p:sldId xmlns:r="http://schemas.openxmlformats.org/officeDocument/2006/relationships" id="259" r:id="Raae1472c692a4c73"/>
-    <p:sldId xmlns:r="http://schemas.openxmlformats.org/officeDocument/2006/relationships" id="260" r:id="Rb44978b98bb84fcc"/>
-    <p:sldId xmlns:r="http://schemas.openxmlformats.org/officeDocument/2006/relationships" id="261" r:id="R31dc3ebf79db4041"/>
-    <p:sldId xmlns:r="http://schemas.openxmlformats.org/officeDocument/2006/relationships" id="262" r:id="R46e30c230351492f"/>
-    <p:sldId xmlns:r="http://schemas.openxmlformats.org/officeDocument/2006/relationships" id="263" r:id="Re0c1367e709d4c7a"/>
-    <p:sldId xmlns:r="http://schemas.openxmlformats.org/officeDocument/2006/relationships" id="264" r:id="Rbf074b30ae5f4aa6"/>
-    <p:sldId xmlns:r="http://schemas.openxmlformats.org/officeDocument/2006/relationships" id="265" r:id="R27744757e0994b5a"/>
-    <p:sldId xmlns:r="http://schemas.openxmlformats.org/officeDocument/2006/relationships" id="266" r:id="Ra45e8f54b7d54997"/>
-    <p:sldId xmlns:r="http://schemas.openxmlformats.org/officeDocument/2006/relationships" id="267" r:id="R3920151dcc504282"/>
-    <p:sldId xmlns:r="http://schemas.openxmlformats.org/officeDocument/2006/relationships" id="268" r:id="R93670c08d33d49f2"/>
-    <p:sldId xmlns:r="http://schemas.openxmlformats.org/officeDocument/2006/relationships" id="269" r:id="R0838ca30e38547ab"/>
-    <p:sldId xmlns:r="http://schemas.openxmlformats.org/officeDocument/2006/relationships" id="270" r:id="Rfb9d802a2dc04698"/>
-    <p:sldId xmlns:r="http://schemas.openxmlformats.org/officeDocument/2006/relationships" id="271" r:id="Rf80b07586ff04ad3"/>
-    <p:sldId xmlns:r="http://schemas.openxmlformats.org/officeDocument/2006/relationships" id="272" r:id="R8d0392344a534397"/>
-    <p:sldId xmlns:r="http://schemas.openxmlformats.org/officeDocument/2006/relationships" id="273" r:id="Raf6353b2eb1b41bf"/>
-    <p:sldId xmlns:r="http://schemas.openxmlformats.org/officeDocument/2006/relationships" id="274" r:id="R832973f328084ab4"/>
-    <p:sldId xmlns:r="http://schemas.openxmlformats.org/officeDocument/2006/relationships" id="275" r:id="R2e04ee3a04094c4d"/>
-    <p:sldId xmlns:r="http://schemas.openxmlformats.org/officeDocument/2006/relationships" id="276" r:id="Rf6781c7ee5fd4577"/>
-    <p:sldId xmlns:r="http://schemas.openxmlformats.org/officeDocument/2006/relationships" id="277" r:id="R84e59695dad542d2"/>
-    <p:sldId xmlns:r="http://schemas.openxmlformats.org/officeDocument/2006/relationships" id="278" r:id="R275237ae53974660"/>
-    <p:sldId xmlns:r="http://schemas.openxmlformats.org/officeDocument/2006/relationships" id="279" r:id="R26a6f77023f3447f"/>
-    <p:sldId xmlns:r="http://schemas.openxmlformats.org/officeDocument/2006/relationships" id="280" r:id="R38a7d1bd7d374d59"/>
-    <p:sldId xmlns:r="http://schemas.openxmlformats.org/officeDocument/2006/relationships" id="281" r:id="Rdd98e5694ccf4171"/>
-    <p:sldId xmlns:r="http://schemas.openxmlformats.org/officeDocument/2006/relationships" id="282" r:id="R92151163538545ad"/>
-    <p:sldId xmlns:r="http://schemas.openxmlformats.org/officeDocument/2006/relationships" id="283" r:id="R69e0fed0b8ca4a56"/>
-    <p:sldId xmlns:r="http://schemas.openxmlformats.org/officeDocument/2006/relationships" id="284" r:id="Re97a5b2db39b42f0"/>
-    <p:sldId xmlns:r="http://schemas.openxmlformats.org/officeDocument/2006/relationships" id="285" r:id="Rb33df00e4d7b49be"/>
-    <p:sldId xmlns:r="http://schemas.openxmlformats.org/officeDocument/2006/relationships" id="286" r:id="R08f2dbf8bdf94d18"/>
-    <p:sldId xmlns:r="http://schemas.openxmlformats.org/officeDocument/2006/relationships" id="287" r:id="R139508ca76a04ed0"/>
+    <p:sldId id="256" r:id="Rf26c61c082b34e56"/>
+    <p:sldId id="257" r:id="R306f1c47cb6343fb"/>
+    <p:sldId id="258" r:id="R904562a8597f4bb7"/>
+    <p:sldId id="259" r:id="Raae1472c692a4c73"/>
+    <p:sldId id="260" r:id="Rb44978b98bb84fcc"/>
+    <p:sldId id="261" r:id="R31dc3ebf79db4041"/>
+    <p:sldId id="262" r:id="R46e30c230351492f"/>
+    <p:sldId id="263" r:id="Re0c1367e709d4c7a"/>
+    <p:sldId id="264" r:id="Rbf074b30ae5f4aa6"/>
+    <p:sldId id="265" r:id="R27744757e0994b5a"/>
+    <p:sldId id="266" r:id="Ra45e8f54b7d54997"/>
+    <p:sldId id="267" r:id="R3920151dcc504282"/>
+    <p:sldId id="268" r:id="R93670c08d33d49f2"/>
+    <p:sldId id="269" r:id="R0838ca30e38547ab"/>
+    <p:sldId id="270" r:id="Rfb9d802a2dc04698"/>
+    <p:sldId id="271" r:id="Rf80b07586ff04ad3"/>
+    <p:sldId id="272" r:id="R8d0392344a534397"/>
+    <p:sldId id="273" r:id="Raf6353b2eb1b41bf"/>
+    <p:sldId id="274" r:id="R832973f328084ab4"/>
+    <p:sldId id="275" r:id="R2e04ee3a04094c4d"/>
+    <p:sldId id="276" r:id="Rf6781c7ee5fd4577"/>
+    <p:sldId id="277" r:id="R84e59695dad542d2"/>
+    <p:sldId id="278" r:id="R275237ae53974660"/>
+    <p:sldId id="279" r:id="R26a6f77023f3447f"/>
+    <p:sldId id="280" r:id="R38a7d1bd7d374d59"/>
+    <p:sldId id="281" r:id="Rdd98e5694ccf4171"/>
+    <p:sldId id="282" r:id="R92151163538545ad"/>
+    <p:sldId id="283" r:id="R69e0fed0b8ca4a56"/>
+    <p:sldId id="284" r:id="Re97a5b2db39b42f0"/>
+    <p:sldId id="285" r:id="Rb33df00e4d7b49be"/>
+    <p:sldId id="286" r:id="R08f2dbf8bdf94d18"/>
   </p:sldIdLst>
   <p:sldSz cx="12192000" cy="6858000"/>
   <p:notesSz cx="6858000" cy="9144000"/>
@@ -2154,76 +2153,6 @@
           <a:p xmlns:a="http://schemas.openxmlformats.org/drawingml/2006/main">
             <a:r>
               <a:t>Sources: ontology/customer-intelligence.ttl; ontology/shapes.ttl; policies/analytics.rego; jobs/semantic_contracts.py; jobs/result_contracts.py; jobs/evaluate_acceptance.py; reports/GOVERNANCE_REPORT.md</a:t>
-            </a:r>
-          </a:p>
-        </p:txBody>
-      </p:sp>
-      <p:sp>
-        <p:nvSpPr>
-          <p:cNvPr id="4" name="Slide Number Placeholder 3"/>
-          <p:cNvSpPr>
-            <a:spLocks xmlns:a="http://schemas.openxmlformats.org/drawingml/2006/main" noGrp="1"/>
-          </p:cNvSpPr>
-          <p:nvPr>
-            <p:ph type="sldNum" idx="5"/>
-          </p:nvPr>
-        </p:nvSpPr>
-        <p:spPr/>
-        <p:txBody>
-          <a:bodyPr xmlns:a="http://schemas.openxmlformats.org/drawingml/2006/main"/>
-          <a:lstStyle xmlns:a="http://schemas.openxmlformats.org/drawingml/2006/main"/>
-          <a:p xmlns:a="http://schemas.openxmlformats.org/drawingml/2006/main"/>
-        </p:txBody>
-      </p:sp>
-    </p:spTree>
-  </p:cSld>
-  <p:clrMapOvr>
-    <a:masterClrMapping xmlns:a="http://schemas.openxmlformats.org/drawingml/2006/main"/>
-  </p:clrMapOvr>
-</p:notes>
-</file>
-
-<file path=ppt/notesSlides/notesSlide32.xml><?xml version="1.0" encoding="utf-8"?>
-<p:notes xmlns:p="http://schemas.openxmlformats.org/presentationml/2006/main">
-  <p:cSld>
-    <p:spTree>
-      <p:nvGrpSpPr>
-        <p:cNvPr id="1" name=""/>
-        <p:cNvGrpSpPr/>
-        <p:nvPr/>
-      </p:nvGrpSpPr>
-      <p:grpSpPr>
-        <a:xfrm xmlns:a="http://schemas.openxmlformats.org/drawingml/2006/main"/>
-      </p:grpSpPr>
-      <p:sp>
-        <p:nvSpPr>
-          <p:cNvPr id="2" name="Slide Image Placeholder 1"/>
-          <p:cNvSpPr>
-            <a:spLocks xmlns:a="http://schemas.openxmlformats.org/drawingml/2006/main" noGrp="1"/>
-          </p:cNvSpPr>
-          <p:nvPr>
-            <p:ph type="sldImg" idx="0"/>
-          </p:nvPr>
-        </p:nvSpPr>
-        <p:spPr/>
-      </p:sp>
-      <p:sp>
-        <p:nvSpPr>
-          <p:cNvPr id="3" name="Notes Placeholder 2"/>
-          <p:cNvSpPr>
-            <a:spLocks xmlns:a="http://schemas.openxmlformats.org/drawingml/2006/main" noGrp="1"/>
-          </p:cNvSpPr>
-          <p:nvPr>
-            <p:ph type="body" idx="1"/>
-          </p:nvPr>
-        </p:nvSpPr>
-        <p:spPr/>
-        <p:txBody>
-          <a:bodyPr xmlns:a="http://schemas.openxmlformats.org/drawingml/2006/main"/>
-          <a:lstStyle xmlns:a="http://schemas.openxmlformats.org/drawingml/2006/main"/>
-          <a:p xmlns:a="http://schemas.openxmlformats.org/drawingml/2006/main">
-            <a:r>
-              <a:t>Project-specific editable diagrams. Sources: README.md; reports/DELIVERY_REPORT.md; reports/CONTEXT_REPORT.md</a:t>
             </a:r>
           </a:p>
         </p:txBody>
@@ -36271,1261 +36200,6 @@
     <p:extLst>
       <p:ext uri="{BB962C8B-B14F-4D97-AF65-F5344CB8AC3E}">
         <p14:creationId xmlns:p14="http://schemas.microsoft.com/office/powerpoint/2010/main" val="1760084894"/>
-      </p:ext>
-    </p:extLst>
-  </p:cSld>
-</p:sld>
-</file>
-
-<file path=ppt/slides/slide32.xml><?xml version="1.0" encoding="utf-8"?>
-<p:sld xmlns:p="http://schemas.openxmlformats.org/presentationml/2006/main">
-  <p:cSld>
-    <p:bg>
-      <p:bgPr>
-        <a:solidFill xmlns:a="http://schemas.openxmlformats.org/drawingml/2006/main">
-          <a:srgbClr val="FAFCFE"/>
-        </a:solidFill>
-      </p:bgPr>
-    </p:bg>
-    <p:spTree>
-      <p:nvGrpSpPr>
-        <p:cNvPr id="1" name=""/>
-        <p:cNvGrpSpPr/>
-        <p:nvPr/>
-      </p:nvGrpSpPr>
-      <p:grpSpPr>
-        <a:xfrm xmlns:a="http://schemas.openxmlformats.org/drawingml/2006/main"/>
-      </p:grpSpPr>
-      <p:sp>
-        <p:nvSpPr>
-          <p:cNvPr id="2" name="">
-            <a:extLst xmlns:a="http://schemas.openxmlformats.org/drawingml/2006/main">
-              <a:ext uri="{FF2B5EF4-FFF2-40B4-BE49-F238E27FC236}">
-                <a16:creationId xmlns:a16="http://schemas.microsoft.com/office/drawing/2014/main" id="{9FF3166C-9909-4064-9AFD-0A3BA9FF7945}"/>
-              </a:ext>
-            </a:extLst>
-          </p:cNvPr>
-          <p:cNvSpPr>
-            <a:spLocks xmlns:a="http://schemas.openxmlformats.org/drawingml/2006/main" noGrp="1"/>
-          </p:cNvSpPr>
-          <p:nvPr/>
-        </p:nvSpPr>
-        <p:spPr>
-          <a:xfrm xmlns:a="http://schemas.openxmlformats.org/drawingml/2006/main">
-            <a:off x="495300" y="266700"/>
-            <a:ext cx="11201400" cy="628650"/>
-          </a:xfrm>
-          <a:prstGeom xmlns:a="http://schemas.openxmlformats.org/drawingml/2006/main" prst="rect">
-            <a:avLst/>
-          </a:prstGeom>
-          <a:noFill xmlns:a="http://schemas.openxmlformats.org/drawingml/2006/main"/>
-          <a:ln xmlns:a="http://schemas.openxmlformats.org/drawingml/2006/main" w="0">
-            <a:noFill/>
-          </a:ln>
-        </p:spPr>
-        <p:txBody>
-          <a:bodyPr xmlns:a="http://schemas.openxmlformats.org/drawingml/2006/main" anchor="ctr"/>
-          <a:lstStyle xmlns:a="http://schemas.openxmlformats.org/drawingml/2006/main">
-            <a:defPPr>
-              <a:defRPr sz="2850" b="1">
-                <a:solidFill>
-                  <a:srgbClr val="102B46"/>
-                </a:solidFill>
-              </a:defRPr>
-            </a:defPPr>
-            <a:lvl1pPr>
-              <a:defRPr sz="2850" b="1">
-                <a:solidFill>
-                  <a:srgbClr val="102B46"/>
-                </a:solidFill>
-              </a:defRPr>
-            </a:lvl1pPr>
-            <a:lvl2pPr>
-              <a:defRPr sz="2850" b="1">
-                <a:solidFill>
-                  <a:srgbClr val="102B46"/>
-                </a:solidFill>
-              </a:defRPr>
-            </a:lvl2pPr>
-            <a:lvl3pPr>
-              <a:defRPr sz="2850" b="1">
-                <a:solidFill>
-                  <a:srgbClr val="102B46"/>
-                </a:solidFill>
-              </a:defRPr>
-            </a:lvl3pPr>
-            <a:lvl4pPr>
-              <a:defRPr sz="2850" b="1">
-                <a:solidFill>
-                  <a:srgbClr val="102B46"/>
-                </a:solidFill>
-              </a:defRPr>
-            </a:lvl4pPr>
-            <a:lvl5pPr>
-              <a:defRPr sz="2850" b="1">
-                <a:solidFill>
-                  <a:srgbClr val="102B46"/>
-                </a:solidFill>
-              </a:defRPr>
-            </a:lvl5pPr>
-            <a:lvl6pPr>
-              <a:defRPr sz="2850" b="1">
-                <a:solidFill>
-                  <a:srgbClr val="102B46"/>
-                </a:solidFill>
-              </a:defRPr>
-            </a:lvl6pPr>
-            <a:lvl7pPr>
-              <a:defRPr sz="2850" b="1">
-                <a:solidFill>
-                  <a:srgbClr val="102B46"/>
-                </a:solidFill>
-              </a:defRPr>
-            </a:lvl7pPr>
-            <a:lvl8pPr>
-              <a:defRPr sz="2850" b="1">
-                <a:solidFill>
-                  <a:srgbClr val="102B46"/>
-                </a:solidFill>
-              </a:defRPr>
-            </a:lvl8pPr>
-            <a:lvl9pPr>
-              <a:defRPr sz="2850" b="1">
-                <a:solidFill>
-                  <a:srgbClr val="102B46"/>
-                </a:solidFill>
-              </a:defRPr>
-            </a:lvl9pPr>
-          </a:lstStyle>
-          <a:p xmlns:a="http://schemas.openxmlformats.org/drawingml/2006/main">
-            <a:pPr>
-              <a:defRPr sz="2850" b="1">
-                <a:solidFill>
-                  <a:srgbClr val="102B46"/>
-                </a:solidFill>
-              </a:defRPr>
-            </a:pPr>
-            <a:r>
-              <a:rPr sz="2850" b="1">
-                <a:solidFill>
-                  <a:srgbClr val="102B46"/>
-                </a:solidFill>
-              </a:rPr>
-              <a:t>การสาธิตและการนำไปพัฒนาต่อ</a:t>
-            </a:r>
-          </a:p>
-        </p:txBody>
-      </p:sp>
-      <p:sp>
-        <p:nvSpPr>
-          <p:cNvPr id="3" name="">
-            <a:extLst xmlns:a="http://schemas.openxmlformats.org/drawingml/2006/main">
-              <a:ext uri="{FF2B5EF4-FFF2-40B4-BE49-F238E27FC236}">
-                <a16:creationId xmlns:a16="http://schemas.microsoft.com/office/drawing/2014/main" id="{327DE4F8-ABEA-4977-B92D-F0902ECC8BE8}"/>
-              </a:ext>
-            </a:extLst>
-          </p:cNvPr>
-          <p:cNvSpPr>
-            <a:spLocks xmlns:a="http://schemas.openxmlformats.org/drawingml/2006/main" noGrp="1"/>
-          </p:cNvSpPr>
-          <p:nvPr/>
-        </p:nvSpPr>
-        <p:spPr>
-          <a:xfrm xmlns:a="http://schemas.openxmlformats.org/drawingml/2006/main">
-            <a:off x="514350" y="962025"/>
-            <a:ext cx="11163300" cy="504825"/>
-          </a:xfrm>
-          <a:prstGeom xmlns:a="http://schemas.openxmlformats.org/drawingml/2006/main" prst="rect">
-            <a:avLst/>
-          </a:prstGeom>
-          <a:noFill xmlns:a="http://schemas.openxmlformats.org/drawingml/2006/main"/>
-          <a:ln xmlns:a="http://schemas.openxmlformats.org/drawingml/2006/main" w="0">
-            <a:noFill/>
-          </a:ln>
-        </p:spPr>
-        <p:txBody>
-          <a:bodyPr xmlns:a="http://schemas.openxmlformats.org/drawingml/2006/main" anchor="ctr"/>
-          <a:lstStyle xmlns:a="http://schemas.openxmlformats.org/drawingml/2006/main">
-            <a:defPPr>
-              <a:defRPr sz="1800" b="0">
-                <a:solidFill>
-                  <a:srgbClr val="4D6577"/>
-                </a:solidFill>
-              </a:defRPr>
-            </a:defPPr>
-            <a:lvl1pPr>
-              <a:defRPr sz="1800" b="0">
-                <a:solidFill>
-                  <a:srgbClr val="4D6577"/>
-                </a:solidFill>
-              </a:defRPr>
-            </a:lvl1pPr>
-            <a:lvl2pPr>
-              <a:defRPr sz="1800" b="0">
-                <a:solidFill>
-                  <a:srgbClr val="4D6577"/>
-                </a:solidFill>
-              </a:defRPr>
-            </a:lvl2pPr>
-            <a:lvl3pPr>
-              <a:defRPr sz="1800" b="0">
-                <a:solidFill>
-                  <a:srgbClr val="4D6577"/>
-                </a:solidFill>
-              </a:defRPr>
-            </a:lvl3pPr>
-            <a:lvl4pPr>
-              <a:defRPr sz="1800" b="0">
-                <a:solidFill>
-                  <a:srgbClr val="4D6577"/>
-                </a:solidFill>
-              </a:defRPr>
-            </a:lvl4pPr>
-            <a:lvl5pPr>
-              <a:defRPr sz="1800" b="0">
-                <a:solidFill>
-                  <a:srgbClr val="4D6577"/>
-                </a:solidFill>
-              </a:defRPr>
-            </a:lvl5pPr>
-            <a:lvl6pPr>
-              <a:defRPr sz="1800" b="0">
-                <a:solidFill>
-                  <a:srgbClr val="4D6577"/>
-                </a:solidFill>
-              </a:defRPr>
-            </a:lvl6pPr>
-            <a:lvl7pPr>
-              <a:defRPr sz="1800" b="0">
-                <a:solidFill>
-                  <a:srgbClr val="4D6577"/>
-                </a:solidFill>
-              </a:defRPr>
-            </a:lvl7pPr>
-            <a:lvl8pPr>
-              <a:defRPr sz="1800" b="0">
-                <a:solidFill>
-                  <a:srgbClr val="4D6577"/>
-                </a:solidFill>
-              </a:defRPr>
-            </a:lvl8pPr>
-            <a:lvl9pPr>
-              <a:defRPr sz="1800" b="0">
-                <a:solidFill>
-                  <a:srgbClr val="4D6577"/>
-                </a:solidFill>
-              </a:defRPr>
-            </a:lvl9pPr>
-          </a:lstStyle>
-          <a:p xmlns:a="http://schemas.openxmlformats.org/drawingml/2006/main">
-            <a:pPr>
-              <a:defRPr sz="1800" b="0">
-                <a:solidFill>
-                  <a:srgbClr val="4D6577"/>
-                </a:solidFill>
-              </a:defRPr>
-            </a:pPr>
-            <a:r>
-              <a:rPr sz="1800" b="0">
-                <a:solidFill>
-                  <a:srgbClr val="4D6577"/>
-                </a:solidFill>
-              </a:rPr>
-              <a:t>Source code และหลักฐานการวัดผลอยู่บน GitHub public</a:t>
-            </a:r>
-          </a:p>
-        </p:txBody>
-      </p:sp>
-      <p:sp>
-        <p:nvSpPr>
-          <p:cNvPr id="4" name="">
-            <a:extLst xmlns:a="http://schemas.openxmlformats.org/drawingml/2006/main">
-              <a:ext uri="{FF2B5EF4-FFF2-40B4-BE49-F238E27FC236}">
-                <a16:creationId xmlns:a16="http://schemas.microsoft.com/office/drawing/2014/main" id="{ED3693B6-FAB8-456B-AA13-EBE43A369B87}"/>
-              </a:ext>
-            </a:extLst>
-          </p:cNvPr>
-          <p:cNvSpPr>
-            <a:spLocks xmlns:a="http://schemas.openxmlformats.org/drawingml/2006/main" noGrp="1"/>
-          </p:cNvSpPr>
-          <p:nvPr/>
-        </p:nvSpPr>
-        <p:spPr>
-          <a:xfrm xmlns:a="http://schemas.openxmlformats.org/drawingml/2006/main">
-            <a:off x="11315700" y="6324600"/>
-            <a:ext cx="476250" cy="323850"/>
-          </a:xfrm>
-          <a:prstGeom xmlns:a="http://schemas.openxmlformats.org/drawingml/2006/main" prst="rect">
-            <a:avLst/>
-          </a:prstGeom>
-          <a:noFill xmlns:a="http://schemas.openxmlformats.org/drawingml/2006/main"/>
-          <a:ln xmlns:a="http://schemas.openxmlformats.org/drawingml/2006/main" w="0">
-            <a:noFill/>
-          </a:ln>
-        </p:spPr>
-        <p:txBody>
-          <a:bodyPr xmlns:a="http://schemas.openxmlformats.org/drawingml/2006/main" anchor="ctr"/>
-          <a:lstStyle xmlns:a="http://schemas.openxmlformats.org/drawingml/2006/main">
-            <a:defPPr>
-              <a:defRPr sz="1500" b="0">
-                <a:solidFill>
-                  <a:srgbClr val="4D6577"/>
-                </a:solidFill>
-              </a:defRPr>
-            </a:defPPr>
-            <a:lvl1pPr>
-              <a:defRPr sz="1500" b="0">
-                <a:solidFill>
-                  <a:srgbClr val="4D6577"/>
-                </a:solidFill>
-              </a:defRPr>
-            </a:lvl1pPr>
-            <a:lvl2pPr>
-              <a:defRPr sz="1500" b="0">
-                <a:solidFill>
-                  <a:srgbClr val="4D6577"/>
-                </a:solidFill>
-              </a:defRPr>
-            </a:lvl2pPr>
-            <a:lvl3pPr>
-              <a:defRPr sz="1500" b="0">
-                <a:solidFill>
-                  <a:srgbClr val="4D6577"/>
-                </a:solidFill>
-              </a:defRPr>
-            </a:lvl3pPr>
-            <a:lvl4pPr>
-              <a:defRPr sz="1500" b="0">
-                <a:solidFill>
-                  <a:srgbClr val="4D6577"/>
-                </a:solidFill>
-              </a:defRPr>
-            </a:lvl4pPr>
-            <a:lvl5pPr>
-              <a:defRPr sz="1500" b="0">
-                <a:solidFill>
-                  <a:srgbClr val="4D6577"/>
-                </a:solidFill>
-              </a:defRPr>
-            </a:lvl5pPr>
-            <a:lvl6pPr>
-              <a:defRPr sz="1500" b="0">
-                <a:solidFill>
-                  <a:srgbClr val="4D6577"/>
-                </a:solidFill>
-              </a:defRPr>
-            </a:lvl6pPr>
-            <a:lvl7pPr>
-              <a:defRPr sz="1500" b="0">
-                <a:solidFill>
-                  <a:srgbClr val="4D6577"/>
-                </a:solidFill>
-              </a:defRPr>
-            </a:lvl7pPr>
-            <a:lvl8pPr>
-              <a:defRPr sz="1500" b="0">
-                <a:solidFill>
-                  <a:srgbClr val="4D6577"/>
-                </a:solidFill>
-              </a:defRPr>
-            </a:lvl8pPr>
-            <a:lvl9pPr>
-              <a:defRPr sz="1500" b="0">
-                <a:solidFill>
-                  <a:srgbClr val="4D6577"/>
-                </a:solidFill>
-              </a:defRPr>
-            </a:lvl9pPr>
-          </a:lstStyle>
-          <a:p xmlns:a="http://schemas.openxmlformats.org/drawingml/2006/main">
-            <a:pPr>
-              <a:defRPr sz="1500" b="0">
-                <a:solidFill>
-                  <a:srgbClr val="4D6577"/>
-                </a:solidFill>
-              </a:defRPr>
-            </a:pPr>
-            <a:r>
-              <a:rPr sz="1500" b="0">
-                <a:solidFill>
-                  <a:srgbClr val="4D6577"/>
-                </a:solidFill>
-              </a:rPr>
-              <a:t>32</a:t>
-            </a:r>
-          </a:p>
-        </p:txBody>
-      </p:sp>
-      <p:sp>
-        <p:nvSpPr>
-          <p:cNvPr id="5" name="">
-            <a:extLst xmlns:a="http://schemas.openxmlformats.org/drawingml/2006/main">
-              <a:ext uri="{FF2B5EF4-FFF2-40B4-BE49-F238E27FC236}">
-                <a16:creationId xmlns:a16="http://schemas.microsoft.com/office/drawing/2014/main" id="{922F7A70-E215-4880-A35C-CF252190A3F2}"/>
-              </a:ext>
-            </a:extLst>
-          </p:cNvPr>
-          <p:cNvSpPr>
-            <a:spLocks xmlns:a="http://schemas.openxmlformats.org/drawingml/2006/main" noGrp="1"/>
-          </p:cNvSpPr>
-          <p:nvPr/>
-        </p:nvSpPr>
-        <p:spPr>
-          <a:xfrm xmlns:a="http://schemas.openxmlformats.org/drawingml/2006/main">
-            <a:off x="571500" y="1895475"/>
-            <a:ext cx="3314700" cy="1066800"/>
-          </a:xfrm>
-          <a:prstGeom xmlns:a="http://schemas.openxmlformats.org/drawingml/2006/main" prst="roundRect">
-            <a:avLst>
-              <a:gd name="adj" fmla="val 7143"/>
-            </a:avLst>
-          </a:prstGeom>
-          <a:solidFill xmlns:a="http://schemas.openxmlformats.org/drawingml/2006/main">
-            <a:srgbClr val="FFF0DD"/>
-          </a:solidFill>
-          <a:ln xmlns:a="http://schemas.openxmlformats.org/drawingml/2006/main" w="9525">
-            <a:solidFill>
-              <a:srgbClr val="BCD1DC"/>
-            </a:solidFill>
-          </a:ln>
-        </p:spPr>
-        <p:txBody>
-          <a:bodyPr xmlns:a="http://schemas.openxmlformats.org/drawingml/2006/main" anchor="ctr"/>
-          <a:lstStyle xmlns:a="http://schemas.openxmlformats.org/drawingml/2006/main">
-            <a:defPPr algn="ctr">
-              <a:defRPr sz="1875">
-                <a:solidFill>
-                  <a:srgbClr val="102B46"/>
-                </a:solidFill>
-              </a:defRPr>
-            </a:defPPr>
-            <a:lvl1pPr algn="ctr">
-              <a:defRPr sz="1875">
-                <a:solidFill>
-                  <a:srgbClr val="102B46"/>
-                </a:solidFill>
-              </a:defRPr>
-            </a:lvl1pPr>
-            <a:lvl2pPr algn="ctr">
-              <a:defRPr sz="1875">
-                <a:solidFill>
-                  <a:srgbClr val="102B46"/>
-                </a:solidFill>
-              </a:defRPr>
-            </a:lvl2pPr>
-            <a:lvl3pPr algn="ctr">
-              <a:defRPr sz="1875">
-                <a:solidFill>
-                  <a:srgbClr val="102B46"/>
-                </a:solidFill>
-              </a:defRPr>
-            </a:lvl3pPr>
-            <a:lvl4pPr algn="ctr">
-              <a:defRPr sz="1875">
-                <a:solidFill>
-                  <a:srgbClr val="102B46"/>
-                </a:solidFill>
-              </a:defRPr>
-            </a:lvl4pPr>
-            <a:lvl5pPr algn="ctr">
-              <a:defRPr sz="1875">
-                <a:solidFill>
-                  <a:srgbClr val="102B46"/>
-                </a:solidFill>
-              </a:defRPr>
-            </a:lvl5pPr>
-            <a:lvl6pPr algn="ctr">
-              <a:defRPr sz="1875">
-                <a:solidFill>
-                  <a:srgbClr val="102B46"/>
-                </a:solidFill>
-              </a:defRPr>
-            </a:lvl6pPr>
-            <a:lvl7pPr algn="ctr">
-              <a:defRPr sz="1875">
-                <a:solidFill>
-                  <a:srgbClr val="102B46"/>
-                </a:solidFill>
-              </a:defRPr>
-            </a:lvl7pPr>
-            <a:lvl8pPr algn="ctr">
-              <a:defRPr sz="1875">
-                <a:solidFill>
-                  <a:srgbClr val="102B46"/>
-                </a:solidFill>
-              </a:defRPr>
-            </a:lvl8pPr>
-            <a:lvl9pPr algn="ctr">
-              <a:defRPr sz="1875">
-                <a:solidFill>
-                  <a:srgbClr val="102B46"/>
-                </a:solidFill>
-              </a:defRPr>
-            </a:lvl9pPr>
-          </a:lstStyle>
-          <a:p xmlns:a="http://schemas.openxmlformats.org/drawingml/2006/main">
-            <a:pPr algn="ctr">
-              <a:defRPr sz="1875">
-                <a:solidFill>
-                  <a:srgbClr val="102B46"/>
-                </a:solidFill>
-              </a:defRPr>
-            </a:pPr>
-            <a:r>
-              <a:rPr sz="1875">
-                <a:solidFill>
-                  <a:srgbClr val="102B46"/>
-                </a:solidFill>
-              </a:rPr>
-              <a:t>เปิด Docker stack</a:t>
-            </a:r>
-          </a:p>
-          <a:p xmlns:a="http://schemas.openxmlformats.org/drawingml/2006/main">
-            <a:pPr algn="ctr">
-              <a:defRPr sz="1875">
-                <a:solidFill>
-                  <a:srgbClr val="102B46"/>
-                </a:solidFill>
-              </a:defRPr>
-            </a:pPr>
-            <a:r>
-              <a:rPr sz="1875">
-                <a:solidFill>
-                  <a:srgbClr val="102B46"/>
-                </a:solidFill>
-              </a:rPr>
-              <a:t>สร้างข้อมูลบน HDFS</a:t>
-            </a:r>
-          </a:p>
-        </p:txBody>
-      </p:sp>
-      <p:sp>
-        <p:nvSpPr>
-          <p:cNvPr id="6" name="">
-            <a:extLst xmlns:a="http://schemas.openxmlformats.org/drawingml/2006/main">
-              <a:ext uri="{FF2B5EF4-FFF2-40B4-BE49-F238E27FC236}">
-                <a16:creationId xmlns:a16="http://schemas.microsoft.com/office/drawing/2014/main" id="{AA128FFD-A8CE-4D63-96FE-89C025CC3331}"/>
-              </a:ext>
-            </a:extLst>
-          </p:cNvPr>
-          <p:cNvSpPr>
-            <a:spLocks xmlns:a="http://schemas.openxmlformats.org/drawingml/2006/main" noGrp="1"/>
-          </p:cNvSpPr>
-          <p:nvPr/>
-        </p:nvSpPr>
-        <p:spPr>
-          <a:xfrm xmlns:a="http://schemas.openxmlformats.org/drawingml/2006/main">
-            <a:off x="3933825" y="2305050"/>
-            <a:ext cx="342900" cy="228600"/>
-          </a:xfrm>
-          <a:prstGeom xmlns:a="http://schemas.openxmlformats.org/drawingml/2006/main" prst="rightArrow">
-            <a:avLst/>
-          </a:prstGeom>
-          <a:solidFill xmlns:a="http://schemas.openxmlformats.org/drawingml/2006/main">
-            <a:srgbClr val="137C68"/>
-          </a:solidFill>
-          <a:ln xmlns:a="http://schemas.openxmlformats.org/drawingml/2006/main" w="0">
-            <a:noFill/>
-          </a:ln>
-        </p:spPr>
-      </p:sp>
-      <p:sp>
-        <p:nvSpPr>
-          <p:cNvPr id="7" name="">
-            <a:extLst xmlns:a="http://schemas.openxmlformats.org/drawingml/2006/main">
-              <a:ext uri="{FF2B5EF4-FFF2-40B4-BE49-F238E27FC236}">
-                <a16:creationId xmlns:a16="http://schemas.microsoft.com/office/drawing/2014/main" id="{C85A8E1F-5877-42CD-81AD-F52358ACD38E}"/>
-              </a:ext>
-            </a:extLst>
-          </p:cNvPr>
-          <p:cNvSpPr>
-            <a:spLocks xmlns:a="http://schemas.openxmlformats.org/drawingml/2006/main" noGrp="1"/>
-          </p:cNvSpPr>
-          <p:nvPr/>
-        </p:nvSpPr>
-        <p:spPr>
-          <a:xfrm xmlns:a="http://schemas.openxmlformats.org/drawingml/2006/main">
-            <a:off x="4343400" y="1895475"/>
-            <a:ext cx="3314700" cy="1066800"/>
-          </a:xfrm>
-          <a:prstGeom xmlns:a="http://schemas.openxmlformats.org/drawingml/2006/main" prst="roundRect">
-            <a:avLst>
-              <a:gd name="adj" fmla="val 7143"/>
-            </a:avLst>
-          </a:prstGeom>
-          <a:solidFill xmlns:a="http://schemas.openxmlformats.org/drawingml/2006/main">
-            <a:srgbClr val="E3F0FF"/>
-          </a:solidFill>
-          <a:ln xmlns:a="http://schemas.openxmlformats.org/drawingml/2006/main" w="9525">
-            <a:solidFill>
-              <a:srgbClr val="BCD1DC"/>
-            </a:solidFill>
-          </a:ln>
-        </p:spPr>
-        <p:txBody>
-          <a:bodyPr xmlns:a="http://schemas.openxmlformats.org/drawingml/2006/main" anchor="ctr"/>
-          <a:lstStyle xmlns:a="http://schemas.openxmlformats.org/drawingml/2006/main">
-            <a:defPPr algn="ctr">
-              <a:defRPr sz="1875">
-                <a:solidFill>
-                  <a:srgbClr val="102B46"/>
-                </a:solidFill>
-              </a:defRPr>
-            </a:defPPr>
-            <a:lvl1pPr algn="ctr">
-              <a:defRPr sz="1875">
-                <a:solidFill>
-                  <a:srgbClr val="102B46"/>
-                </a:solidFill>
-              </a:defRPr>
-            </a:lvl1pPr>
-            <a:lvl2pPr algn="ctr">
-              <a:defRPr sz="1875">
-                <a:solidFill>
-                  <a:srgbClr val="102B46"/>
-                </a:solidFill>
-              </a:defRPr>
-            </a:lvl2pPr>
-            <a:lvl3pPr algn="ctr">
-              <a:defRPr sz="1875">
-                <a:solidFill>
-                  <a:srgbClr val="102B46"/>
-                </a:solidFill>
-              </a:defRPr>
-            </a:lvl3pPr>
-            <a:lvl4pPr algn="ctr">
-              <a:defRPr sz="1875">
-                <a:solidFill>
-                  <a:srgbClr val="102B46"/>
-                </a:solidFill>
-              </a:defRPr>
-            </a:lvl4pPr>
-            <a:lvl5pPr algn="ctr">
-              <a:defRPr sz="1875">
-                <a:solidFill>
-                  <a:srgbClr val="102B46"/>
-                </a:solidFill>
-              </a:defRPr>
-            </a:lvl5pPr>
-            <a:lvl6pPr algn="ctr">
-              <a:defRPr sz="1875">
-                <a:solidFill>
-                  <a:srgbClr val="102B46"/>
-                </a:solidFill>
-              </a:defRPr>
-            </a:lvl6pPr>
-            <a:lvl7pPr algn="ctr">
-              <a:defRPr sz="1875">
-                <a:solidFill>
-                  <a:srgbClr val="102B46"/>
-                </a:solidFill>
-              </a:defRPr>
-            </a:lvl7pPr>
-            <a:lvl8pPr algn="ctr">
-              <a:defRPr sz="1875">
-                <a:solidFill>
-                  <a:srgbClr val="102B46"/>
-                </a:solidFill>
-              </a:defRPr>
-            </a:lvl8pPr>
-            <a:lvl9pPr algn="ctr">
-              <a:defRPr sz="1875">
-                <a:solidFill>
-                  <a:srgbClr val="102B46"/>
-                </a:solidFill>
-              </a:defRPr>
-            </a:lvl9pPr>
-          </a:lstStyle>
-          <a:p xmlns:a="http://schemas.openxmlformats.org/drawingml/2006/main">
-            <a:pPr algn="ctr">
-              <a:defRPr sz="1875">
-                <a:solidFill>
-                  <a:srgbClr val="102B46"/>
-                </a:solidFill>
-              </a:defRPr>
-            </a:pPr>
-            <a:r>
-              <a:rPr sz="1875">
-                <a:solidFill>
-                  <a:srgbClr val="102B46"/>
-                </a:solidFill>
-              </a:rPr>
-              <a:t>เปิด Web app</a:t>
-            </a:r>
-          </a:p>
-          <a:p xmlns:a="http://schemas.openxmlformats.org/drawingml/2006/main">
-            <a:pPr algn="ctr">
-              <a:defRPr sz="1875">
-                <a:solidFill>
-                  <a:srgbClr val="102B46"/>
-                </a:solidFill>
-              </a:defRPr>
-            </a:pPr>
-            <a:r>
-              <a:rPr sz="1875">
-                <a:solidFill>
-                  <a:srgbClr val="102B46"/>
-                </a:solidFill>
-              </a:rPr>
-              <a:t>ถามพร้อมช่วงเวลา</a:t>
-            </a:r>
-          </a:p>
-        </p:txBody>
-      </p:sp>
-      <p:sp>
-        <p:nvSpPr>
-          <p:cNvPr id="8" name="">
-            <a:extLst xmlns:a="http://schemas.openxmlformats.org/drawingml/2006/main">
-              <a:ext uri="{FF2B5EF4-FFF2-40B4-BE49-F238E27FC236}">
-                <a16:creationId xmlns:a16="http://schemas.microsoft.com/office/drawing/2014/main" id="{A83B93DD-8F20-4B04-942A-36504B9358DB}"/>
-              </a:ext>
-            </a:extLst>
-          </p:cNvPr>
-          <p:cNvSpPr>
-            <a:spLocks xmlns:a="http://schemas.openxmlformats.org/drawingml/2006/main" noGrp="1"/>
-          </p:cNvSpPr>
-          <p:nvPr/>
-        </p:nvSpPr>
-        <p:spPr>
-          <a:xfrm xmlns:a="http://schemas.openxmlformats.org/drawingml/2006/main">
-            <a:off x="7705725" y="2305050"/>
-            <a:ext cx="342900" cy="228600"/>
-          </a:xfrm>
-          <a:prstGeom xmlns:a="http://schemas.openxmlformats.org/drawingml/2006/main" prst="rightArrow">
-            <a:avLst/>
-          </a:prstGeom>
-          <a:solidFill xmlns:a="http://schemas.openxmlformats.org/drawingml/2006/main">
-            <a:srgbClr val="137C68"/>
-          </a:solidFill>
-          <a:ln xmlns:a="http://schemas.openxmlformats.org/drawingml/2006/main" w="0">
-            <a:noFill/>
-          </a:ln>
-        </p:spPr>
-      </p:sp>
-      <p:sp>
-        <p:nvSpPr>
-          <p:cNvPr id="9" name="">
-            <a:extLst xmlns:a="http://schemas.openxmlformats.org/drawingml/2006/main">
-              <a:ext uri="{FF2B5EF4-FFF2-40B4-BE49-F238E27FC236}">
-                <a16:creationId xmlns:a16="http://schemas.microsoft.com/office/drawing/2014/main" id="{3C93BD92-D7AD-40F6-B1F7-C4E1197E63A7}"/>
-              </a:ext>
-            </a:extLst>
-          </p:cNvPr>
-          <p:cNvSpPr>
-            <a:spLocks xmlns:a="http://schemas.openxmlformats.org/drawingml/2006/main" noGrp="1"/>
-          </p:cNvSpPr>
-          <p:nvPr/>
-        </p:nvSpPr>
-        <p:spPr>
-          <a:xfrm xmlns:a="http://schemas.openxmlformats.org/drawingml/2006/main">
-            <a:off x="8115300" y="1895475"/>
-            <a:ext cx="3314700" cy="1066800"/>
-          </a:xfrm>
-          <a:prstGeom xmlns:a="http://schemas.openxmlformats.org/drawingml/2006/main" prst="roundRect">
-            <a:avLst>
-              <a:gd name="adj" fmla="val 7143"/>
-            </a:avLst>
-          </a:prstGeom>
-          <a:solidFill xmlns:a="http://schemas.openxmlformats.org/drawingml/2006/main">
-            <a:srgbClr val="DDF5EC"/>
-          </a:solidFill>
-          <a:ln xmlns:a="http://schemas.openxmlformats.org/drawingml/2006/main" w="9525">
-            <a:solidFill>
-              <a:srgbClr val="BCD1DC"/>
-            </a:solidFill>
-          </a:ln>
-        </p:spPr>
-        <p:txBody>
-          <a:bodyPr xmlns:a="http://schemas.openxmlformats.org/drawingml/2006/main" anchor="ctr"/>
-          <a:lstStyle xmlns:a="http://schemas.openxmlformats.org/drawingml/2006/main">
-            <a:defPPr algn="ctr">
-              <a:defRPr sz="1875">
-                <a:solidFill>
-                  <a:srgbClr val="102B46"/>
-                </a:solidFill>
-              </a:defRPr>
-            </a:defPPr>
-            <a:lvl1pPr algn="ctr">
-              <a:defRPr sz="1875">
-                <a:solidFill>
-                  <a:srgbClr val="102B46"/>
-                </a:solidFill>
-              </a:defRPr>
-            </a:lvl1pPr>
-            <a:lvl2pPr algn="ctr">
-              <a:defRPr sz="1875">
-                <a:solidFill>
-                  <a:srgbClr val="102B46"/>
-                </a:solidFill>
-              </a:defRPr>
-            </a:lvl2pPr>
-            <a:lvl3pPr algn="ctr">
-              <a:defRPr sz="1875">
-                <a:solidFill>
-                  <a:srgbClr val="102B46"/>
-                </a:solidFill>
-              </a:defRPr>
-            </a:lvl3pPr>
-            <a:lvl4pPr algn="ctr">
-              <a:defRPr sz="1875">
-                <a:solidFill>
-                  <a:srgbClr val="102B46"/>
-                </a:solidFill>
-              </a:defRPr>
-            </a:lvl4pPr>
-            <a:lvl5pPr algn="ctr">
-              <a:defRPr sz="1875">
-                <a:solidFill>
-                  <a:srgbClr val="102B46"/>
-                </a:solidFill>
-              </a:defRPr>
-            </a:lvl5pPr>
-            <a:lvl6pPr algn="ctr">
-              <a:defRPr sz="1875">
-                <a:solidFill>
-                  <a:srgbClr val="102B46"/>
-                </a:solidFill>
-              </a:defRPr>
-            </a:lvl6pPr>
-            <a:lvl7pPr algn="ctr">
-              <a:defRPr sz="1875">
-                <a:solidFill>
-                  <a:srgbClr val="102B46"/>
-                </a:solidFill>
-              </a:defRPr>
-            </a:lvl7pPr>
-            <a:lvl8pPr algn="ctr">
-              <a:defRPr sz="1875">
-                <a:solidFill>
-                  <a:srgbClr val="102B46"/>
-                </a:solidFill>
-              </a:defRPr>
-            </a:lvl8pPr>
-            <a:lvl9pPr algn="ctr">
-              <a:defRPr sz="1875">
-                <a:solidFill>
-                  <a:srgbClr val="102B46"/>
-                </a:solidFill>
-              </a:defRPr>
-            </a:lvl9pPr>
-          </a:lstStyle>
-          <a:p xmlns:a="http://schemas.openxmlformats.org/drawingml/2006/main">
-            <a:pPr algn="ctr">
-              <a:defRPr sz="1875">
-                <a:solidFill>
-                  <a:srgbClr val="102B46"/>
-                </a:solidFill>
-              </a:defRPr>
-            </a:pPr>
-            <a:r>
-              <a:rPr sz="1875">
-                <a:solidFill>
-                  <a:srgbClr val="102B46"/>
-                </a:solidFill>
-              </a:rPr>
-              <a:t>ตรวจผล</a:t>
-            </a:r>
-          </a:p>
-          <a:p xmlns:a="http://schemas.openxmlformats.org/drawingml/2006/main">
-            <a:pPr algn="ctr">
-              <a:defRPr sz="1875">
-                <a:solidFill>
-                  <a:srgbClr val="102B46"/>
-                </a:solidFill>
-              </a:defRPr>
-            </a:pPr>
-            <a:r>
-              <a:rPr sz="1875">
-                <a:solidFill>
-                  <a:srgbClr val="102B46"/>
-                </a:solidFill>
-              </a:rPr>
-              <a:t>SQL / evidence / trace</a:t>
-            </a:r>
-          </a:p>
-        </p:txBody>
-      </p:sp>
-      <p:sp>
-        <p:nvSpPr>
-          <p:cNvPr id="10" name="">
-            <a:extLst xmlns:a="http://schemas.openxmlformats.org/drawingml/2006/main">
-              <a:ext uri="{FF2B5EF4-FFF2-40B4-BE49-F238E27FC236}">
-                <a16:creationId xmlns:a16="http://schemas.microsoft.com/office/drawing/2014/main" id="{F628FA66-8F29-472A-8618-B02D864C3F2A}"/>
-              </a:ext>
-            </a:extLst>
-          </p:cNvPr>
-          <p:cNvSpPr>
-            <a:spLocks xmlns:a="http://schemas.openxmlformats.org/drawingml/2006/main" noGrp="1"/>
-          </p:cNvSpPr>
-          <p:nvPr/>
-        </p:nvSpPr>
-        <p:spPr>
-          <a:xfrm xmlns:a="http://schemas.openxmlformats.org/drawingml/2006/main">
-            <a:off x="619125" y="3781425"/>
-            <a:ext cx="10953750" cy="590550"/>
-          </a:xfrm>
-          <a:prstGeom xmlns:a="http://schemas.openxmlformats.org/drawingml/2006/main" prst="rect">
-            <a:avLst/>
-          </a:prstGeom>
-          <a:noFill xmlns:a="http://schemas.openxmlformats.org/drawingml/2006/main"/>
-          <a:ln xmlns:a="http://schemas.openxmlformats.org/drawingml/2006/main" w="0">
-            <a:noFill/>
-          </a:ln>
-        </p:spPr>
-        <p:txBody>
-          <a:bodyPr xmlns:a="http://schemas.openxmlformats.org/drawingml/2006/main" anchor="ctr"/>
-          <a:lstStyle xmlns:a="http://schemas.openxmlformats.org/drawingml/2006/main">
-            <a:defPPr>
-              <a:defRPr sz="2775" b="1">
-                <a:solidFill>
-                  <a:srgbClr val="102B46"/>
-                </a:solidFill>
-              </a:defRPr>
-            </a:defPPr>
-            <a:lvl1pPr>
-              <a:defRPr sz="2775" b="1">
-                <a:solidFill>
-                  <a:srgbClr val="102B46"/>
-                </a:solidFill>
-              </a:defRPr>
-            </a:lvl1pPr>
-            <a:lvl2pPr>
-              <a:defRPr sz="2775" b="1">
-                <a:solidFill>
-                  <a:srgbClr val="102B46"/>
-                </a:solidFill>
-              </a:defRPr>
-            </a:lvl2pPr>
-            <a:lvl3pPr>
-              <a:defRPr sz="2775" b="1">
-                <a:solidFill>
-                  <a:srgbClr val="102B46"/>
-                </a:solidFill>
-              </a:defRPr>
-            </a:lvl3pPr>
-            <a:lvl4pPr>
-              <a:defRPr sz="2775" b="1">
-                <a:solidFill>
-                  <a:srgbClr val="102B46"/>
-                </a:solidFill>
-              </a:defRPr>
-            </a:lvl4pPr>
-            <a:lvl5pPr>
-              <a:defRPr sz="2775" b="1">
-                <a:solidFill>
-                  <a:srgbClr val="102B46"/>
-                </a:solidFill>
-              </a:defRPr>
-            </a:lvl5pPr>
-            <a:lvl6pPr>
-              <a:defRPr sz="2775" b="1">
-                <a:solidFill>
-                  <a:srgbClr val="102B46"/>
-                </a:solidFill>
-              </a:defRPr>
-            </a:lvl6pPr>
-            <a:lvl7pPr>
-              <a:defRPr sz="2775" b="1">
-                <a:solidFill>
-                  <a:srgbClr val="102B46"/>
-                </a:solidFill>
-              </a:defRPr>
-            </a:lvl7pPr>
-            <a:lvl8pPr>
-              <a:defRPr sz="2775" b="1">
-                <a:solidFill>
-                  <a:srgbClr val="102B46"/>
-                </a:solidFill>
-              </a:defRPr>
-            </a:lvl8pPr>
-            <a:lvl9pPr>
-              <a:defRPr sz="2775" b="1">
-                <a:solidFill>
-                  <a:srgbClr val="102B46"/>
-                </a:solidFill>
-              </a:defRPr>
-            </a:lvl9pPr>
-          </a:lstStyle>
-          <a:p xmlns:a="http://schemas.openxmlformats.org/drawingml/2006/main">
-            <a:pPr>
-              <a:defRPr sz="2775" b="1">
-                <a:solidFill>
-                  <a:srgbClr val="102B46"/>
-                </a:solidFill>
-              </a:defRPr>
-            </a:pPr>
-            <a:r>
-              <a:rPr sz="2775" b="1">
-                <a:solidFill>
-                  <a:srgbClr val="102B46"/>
-                </a:solidFill>
-              </a:rPr>
-              <a:t>customer-intelligence-agent-spark-hdfs</a:t>
-            </a:r>
-          </a:p>
-        </p:txBody>
-      </p:sp>
-      <p:sp>
-        <p:nvSpPr>
-          <p:cNvPr id="11" name="">
-            <a:extLst xmlns:a="http://schemas.openxmlformats.org/drawingml/2006/main">
-              <a:ext uri="{FF2B5EF4-FFF2-40B4-BE49-F238E27FC236}">
-                <a16:creationId xmlns:a16="http://schemas.microsoft.com/office/drawing/2014/main" id="{F34F7789-0A24-49D6-8D62-12B3130C17A6}"/>
-              </a:ext>
-            </a:extLst>
-          </p:cNvPr>
-          <p:cNvSpPr>
-            <a:spLocks xmlns:a="http://schemas.openxmlformats.org/drawingml/2006/main" noGrp="1"/>
-          </p:cNvSpPr>
-          <p:nvPr/>
-        </p:nvSpPr>
-        <p:spPr>
-          <a:xfrm xmlns:a="http://schemas.openxmlformats.org/drawingml/2006/main">
-            <a:off x="619125" y="4543425"/>
-            <a:ext cx="10953750" cy="781050"/>
-          </a:xfrm>
-          <a:prstGeom xmlns:a="http://schemas.openxmlformats.org/drawingml/2006/main" prst="rect">
-            <a:avLst/>
-          </a:prstGeom>
-          <a:noFill xmlns:a="http://schemas.openxmlformats.org/drawingml/2006/main"/>
-          <a:ln xmlns:a="http://schemas.openxmlformats.org/drawingml/2006/main" w="0">
-            <a:noFill/>
-          </a:ln>
-        </p:spPr>
-        <p:txBody>
-          <a:bodyPr xmlns:a="http://schemas.openxmlformats.org/drawingml/2006/main" anchor="ctr"/>
-          <a:lstStyle xmlns:a="http://schemas.openxmlformats.org/drawingml/2006/main">
-            <a:defPPr>
-              <a:defRPr sz="2025" b="0">
-                <a:solidFill>
-                  <a:srgbClr val="4D6577"/>
-                </a:solidFill>
-              </a:defRPr>
-            </a:defPPr>
-            <a:lvl1pPr>
-              <a:defRPr sz="2025" b="0">
-                <a:solidFill>
-                  <a:srgbClr val="4D6577"/>
-                </a:solidFill>
-              </a:defRPr>
-            </a:lvl1pPr>
-            <a:lvl2pPr>
-              <a:defRPr sz="2025" b="0">
-                <a:solidFill>
-                  <a:srgbClr val="4D6577"/>
-                </a:solidFill>
-              </a:defRPr>
-            </a:lvl2pPr>
-            <a:lvl3pPr>
-              <a:defRPr sz="2025" b="0">
-                <a:solidFill>
-                  <a:srgbClr val="4D6577"/>
-                </a:solidFill>
-              </a:defRPr>
-            </a:lvl3pPr>
-            <a:lvl4pPr>
-              <a:defRPr sz="2025" b="0">
-                <a:solidFill>
-                  <a:srgbClr val="4D6577"/>
-                </a:solidFill>
-              </a:defRPr>
-            </a:lvl4pPr>
-            <a:lvl5pPr>
-              <a:defRPr sz="2025" b="0">
-                <a:solidFill>
-                  <a:srgbClr val="4D6577"/>
-                </a:solidFill>
-              </a:defRPr>
-            </a:lvl5pPr>
-            <a:lvl6pPr>
-              <a:defRPr sz="2025" b="0">
-                <a:solidFill>
-                  <a:srgbClr val="4D6577"/>
-                </a:solidFill>
-              </a:defRPr>
-            </a:lvl6pPr>
-            <a:lvl7pPr>
-              <a:defRPr sz="2025" b="0">
-                <a:solidFill>
-                  <a:srgbClr val="4D6577"/>
-                </a:solidFill>
-              </a:defRPr>
-            </a:lvl7pPr>
-            <a:lvl8pPr>
-              <a:defRPr sz="2025" b="0">
-                <a:solidFill>
-                  <a:srgbClr val="4D6577"/>
-                </a:solidFill>
-              </a:defRPr>
-            </a:lvl8pPr>
-            <a:lvl9pPr>
-              <a:defRPr sz="2025" b="0">
-                <a:solidFill>
-                  <a:srgbClr val="4D6577"/>
-                </a:solidFill>
-              </a:defRPr>
-            </a:lvl9pPr>
-          </a:lstStyle>
-          <a:p xmlns:a="http://schemas.openxmlformats.org/drawingml/2006/main">
-            <a:pPr>
-              <a:defRPr sz="2025" b="0">
-                <a:solidFill>
-                  <a:srgbClr val="4D6577"/>
-                </a:solidFill>
-              </a:defRPr>
-            </a:pPr>
-            <a:r>
-              <a:rPr sz="2025" b="0">
-                <a:solidFill>
-                  <a:srgbClr val="4D6577"/>
-                </a:solidFill>
-              </a:rPr>
-              <a:t>github.com/NATTAPAT-LEUNGRUNGSAP/</a:t>
-            </a:r>
-          </a:p>
-          <a:p xmlns:a="http://schemas.openxmlformats.org/drawingml/2006/main">
-            <a:pPr>
-              <a:defRPr sz="2025" b="0">
-                <a:solidFill>
-                  <a:srgbClr val="4D6577"/>
-                </a:solidFill>
-              </a:defRPr>
-            </a:pPr>
-            <a:r>
-              <a:rPr sz="2025" b="0">
-                <a:solidFill>
-                  <a:srgbClr val="4D6577"/>
-                </a:solidFill>
-              </a:rPr>
-              <a:t>customer-intelligence-agent-spark-hdfs</a:t>
-            </a:r>
-          </a:p>
-        </p:txBody>
-      </p:sp>
-      <p:sp>
-        <p:nvSpPr>
-          <p:cNvPr id="12" name="">
-            <a:extLst xmlns:a="http://schemas.openxmlformats.org/drawingml/2006/main">
-              <a:ext uri="{FF2B5EF4-FFF2-40B4-BE49-F238E27FC236}">
-                <a16:creationId xmlns:a16="http://schemas.microsoft.com/office/drawing/2014/main" id="{40C89ADC-8B6F-4491-BE72-8FBFB95C2602}"/>
-              </a:ext>
-            </a:extLst>
-          </p:cNvPr>
-          <p:cNvSpPr>
-            <a:spLocks xmlns:a="http://schemas.openxmlformats.org/drawingml/2006/main" noGrp="1"/>
-          </p:cNvSpPr>
-          <p:nvPr/>
-        </p:nvSpPr>
-        <p:spPr>
-          <a:xfrm xmlns:a="http://schemas.openxmlformats.org/drawingml/2006/main">
-            <a:off x="514350" y="5781675"/>
-            <a:ext cx="11049000" cy="609600"/>
-          </a:xfrm>
-          <a:prstGeom xmlns:a="http://schemas.openxmlformats.org/drawingml/2006/main" prst="rect">
-            <a:avLst/>
-          </a:prstGeom>
-          <a:noFill xmlns:a="http://schemas.openxmlformats.org/drawingml/2006/main"/>
-          <a:ln xmlns:a="http://schemas.openxmlformats.org/drawingml/2006/main" w="0">
-            <a:noFill/>
-          </a:ln>
-        </p:spPr>
-        <p:txBody>
-          <a:bodyPr xmlns:a="http://schemas.openxmlformats.org/drawingml/2006/main" anchor="ctr"/>
-          <a:lstStyle xmlns:a="http://schemas.openxmlformats.org/drawingml/2006/main">
-            <a:defPPr>
-              <a:defRPr sz="1725" b="0">
-                <a:solidFill>
-                  <a:srgbClr val="4D6577"/>
-                </a:solidFill>
-              </a:defRPr>
-            </a:defPPr>
-            <a:lvl1pPr>
-              <a:defRPr sz="1725" b="0">
-                <a:solidFill>
-                  <a:srgbClr val="4D6577"/>
-                </a:solidFill>
-              </a:defRPr>
-            </a:lvl1pPr>
-            <a:lvl2pPr>
-              <a:defRPr sz="1725" b="0">
-                <a:solidFill>
-                  <a:srgbClr val="4D6577"/>
-                </a:solidFill>
-              </a:defRPr>
-            </a:lvl2pPr>
-            <a:lvl3pPr>
-              <a:defRPr sz="1725" b="0">
-                <a:solidFill>
-                  <a:srgbClr val="4D6577"/>
-                </a:solidFill>
-              </a:defRPr>
-            </a:lvl3pPr>
-            <a:lvl4pPr>
-              <a:defRPr sz="1725" b="0">
-                <a:solidFill>
-                  <a:srgbClr val="4D6577"/>
-                </a:solidFill>
-              </a:defRPr>
-            </a:lvl4pPr>
-            <a:lvl5pPr>
-              <a:defRPr sz="1725" b="0">
-                <a:solidFill>
-                  <a:srgbClr val="4D6577"/>
-                </a:solidFill>
-              </a:defRPr>
-            </a:lvl5pPr>
-            <a:lvl6pPr>
-              <a:defRPr sz="1725" b="0">
-                <a:solidFill>
-                  <a:srgbClr val="4D6577"/>
-                </a:solidFill>
-              </a:defRPr>
-            </a:lvl6pPr>
-            <a:lvl7pPr>
-              <a:defRPr sz="1725" b="0">
-                <a:solidFill>
-                  <a:srgbClr val="4D6577"/>
-                </a:solidFill>
-              </a:defRPr>
-            </a:lvl7pPr>
-            <a:lvl8pPr>
-              <a:defRPr sz="1725" b="0">
-                <a:solidFill>
-                  <a:srgbClr val="4D6577"/>
-                </a:solidFill>
-              </a:defRPr>
-            </a:lvl8pPr>
-            <a:lvl9pPr>
-              <a:defRPr sz="1725" b="0">
-                <a:solidFill>
-                  <a:srgbClr val="4D6577"/>
-                </a:solidFill>
-              </a:defRPr>
-            </a:lvl9pPr>
-          </a:lstStyle>
-          <a:p xmlns:a="http://schemas.openxmlformats.org/drawingml/2006/main">
-            <a:pPr>
-              <a:defRPr sz="1725" b="0">
-                <a:solidFill>
-                  <a:srgbClr val="4D6577"/>
-                </a:solidFill>
-              </a:defRPr>
-            </a:pPr>
-            <a:r>
-              <a:rPr sz="1725" b="0">
-                <a:solidFill>
-                  <a:srgbClr val="4D6577"/>
-                </a:solidFill>
-              </a:rPr>
-              <a:t>Repository เก็บ source, setup, tests และรายงาน • Web app รันบนเครื่องที่เปิด stack</a:t>
-            </a:r>
-          </a:p>
-        </p:txBody>
-      </p:sp>
-    </p:spTree>
-    <p:extLst>
-      <p:ext uri="{BB962C8B-B14F-4D97-AF65-F5344CB8AC3E}">
-        <p14:creationId xmlns:p14="http://schemas.microsoft.com/office/powerpoint/2010/main" val="1274805004"/>
       </p:ext>
     </p:extLst>
   </p:cSld>

</xml_diff>